<commit_message>
Rename Model.dll and Logic.dll
</commit_message>
<xml_diff>
--- a/Reference/DeviceIdentifierProgress.pptx
+++ b/Reference/DeviceIdentifierProgress.pptx
@@ -326,7 +326,7 @@
           <a:p>
             <a:fld id="{5BCAD085-E8A6-8845-BD4E-CB4CCA059FC4}" type="datetimeFigureOut">
               <a:rPr lang="en-US" smtClean="0"/>
-              <a:t>9/2/2026</a:t>
+              <a:t>9/22/2026</a:t>
             </a:fld>
             <a:endParaRPr lang="en-US"/>
           </a:p>
@@ -494,7 +494,7 @@
           <a:p>
             <a:fld id="{5BCAD085-E8A6-8845-BD4E-CB4CCA059FC4}" type="datetimeFigureOut">
               <a:rPr lang="en-US" smtClean="0"/>
-              <a:t>9/2/2026</a:t>
+              <a:t>9/22/2026</a:t>
             </a:fld>
             <a:endParaRPr lang="en-US"/>
           </a:p>
@@ -672,7 +672,7 @@
           <a:p>
             <a:fld id="{5BCAD085-E8A6-8845-BD4E-CB4CCA059FC4}" type="datetimeFigureOut">
               <a:rPr lang="en-US" smtClean="0"/>
-              <a:t>9/2/2026</a:t>
+              <a:t>9/22/2026</a:t>
             </a:fld>
             <a:endParaRPr lang="en-US"/>
           </a:p>
@@ -877,7 +877,7 @@
           <a:p>
             <a:fld id="{1CD01395-AC05-405C-BAB9-E5D2B9FDBB40}" type="datetimeFigureOut">
               <a:rPr lang="en-MY" smtClean="0"/>
-              <a:t>2/9/2026</a:t>
+              <a:t>22/9/2026</a:t>
             </a:fld>
             <a:endParaRPr lang="en-MY"/>
           </a:p>
@@ -1045,7 +1045,7 @@
           <a:p>
             <a:fld id="{5BCAD085-E8A6-8845-BD4E-CB4CCA059FC4}" type="datetimeFigureOut">
               <a:rPr lang="en-US" smtClean="0"/>
-              <a:t>9/2/2026</a:t>
+              <a:t>9/22/2026</a:t>
             </a:fld>
             <a:endParaRPr lang="en-US"/>
           </a:p>
@@ -1290,7 +1290,7 @@
           <a:p>
             <a:fld id="{5BCAD085-E8A6-8845-BD4E-CB4CCA059FC4}" type="datetimeFigureOut">
               <a:rPr lang="en-US" smtClean="0"/>
-              <a:t>9/2/2026</a:t>
+              <a:t>9/22/2026</a:t>
             </a:fld>
             <a:endParaRPr lang="en-US"/>
           </a:p>
@@ -1575,7 +1575,7 @@
           <a:p>
             <a:fld id="{5BCAD085-E8A6-8845-BD4E-CB4CCA059FC4}" type="datetimeFigureOut">
               <a:rPr lang="en-US" smtClean="0"/>
-              <a:t>9/2/2026</a:t>
+              <a:t>9/22/2026</a:t>
             </a:fld>
             <a:endParaRPr lang="en-US"/>
           </a:p>
@@ -1994,7 +1994,7 @@
           <a:p>
             <a:fld id="{5BCAD085-E8A6-8845-BD4E-CB4CCA059FC4}" type="datetimeFigureOut">
               <a:rPr lang="en-US" smtClean="0"/>
-              <a:t>9/2/2026</a:t>
+              <a:t>9/22/2026</a:t>
             </a:fld>
             <a:endParaRPr lang="en-US"/>
           </a:p>
@@ -2111,7 +2111,7 @@
           <a:p>
             <a:fld id="{5BCAD085-E8A6-8845-BD4E-CB4CCA059FC4}" type="datetimeFigureOut">
               <a:rPr lang="en-US" smtClean="0"/>
-              <a:t>9/2/2026</a:t>
+              <a:t>9/22/2026</a:t>
             </a:fld>
             <a:endParaRPr lang="en-US"/>
           </a:p>
@@ -2206,7 +2206,7 @@
           <a:p>
             <a:fld id="{5BCAD085-E8A6-8845-BD4E-CB4CCA059FC4}" type="datetimeFigureOut">
               <a:rPr lang="en-US" smtClean="0"/>
-              <a:t>9/2/2026</a:t>
+              <a:t>9/22/2026</a:t>
             </a:fld>
             <a:endParaRPr lang="en-US"/>
           </a:p>
@@ -2481,7 +2481,7 @@
           <a:p>
             <a:fld id="{5BCAD085-E8A6-8845-BD4E-CB4CCA059FC4}" type="datetimeFigureOut">
               <a:rPr lang="en-US" smtClean="0"/>
-              <a:t>9/2/2026</a:t>
+              <a:t>9/22/2026</a:t>
             </a:fld>
             <a:endParaRPr lang="en-US"/>
           </a:p>
@@ -2733,7 +2733,7 @@
           <a:p>
             <a:fld id="{5BCAD085-E8A6-8845-BD4E-CB4CCA059FC4}" type="datetimeFigureOut">
               <a:rPr lang="en-US" smtClean="0"/>
-              <a:t>9/2/2026</a:t>
+              <a:t>9/22/2026</a:t>
             </a:fld>
             <a:endParaRPr lang="en-US"/>
           </a:p>
@@ -2944,7 +2944,7 @@
           <a:p>
             <a:fld id="{5BCAD085-E8A6-8845-BD4E-CB4CCA059FC4}" type="datetimeFigureOut">
               <a:rPr lang="en-US" smtClean="0"/>
-              <a:t>9/2/2026</a:t>
+              <a:t>9/22/2026</a:t>
             </a:fld>
             <a:endParaRPr lang="en-US"/>
           </a:p>
@@ -5219,7 +5219,7 @@
                     <a:p>
                       <a:pPr algn="l"/>
                       <a:r>
-                        <a:rPr sz="950" b="1">
+                        <a:rPr sz="950" b="1" dirty="0">
                           <a:solidFill>
                             <a:srgbClr val="FFFFFF"/>
                           </a:solidFill>
@@ -5873,13 +5873,40 @@
                     <a:p>
                       <a:pPr algn="l"/>
                       <a:r>
-                        <a:rPr sz="1050" b="0">
+                        <a:rPr lang="en-MY" sz="1050" b="0" dirty="0">
                           <a:solidFill>
                             <a:srgbClr val="4E5A66"/>
                           </a:solidFill>
                           <a:latin typeface="Calibri"/>
                         </a:rPr>
-                        <a:t>Model.dll and Logic.dll, .NET 10</a:t>
+                        <a:t>XenAnalyticModel.dll</a:t>
+                      </a:r>
+                      <a:r>
+                        <a:rPr sz="1050" b="0" dirty="0">
+                          <a:solidFill>
+                            <a:srgbClr val="4E5A66"/>
+                          </a:solidFill>
+                          <a:latin typeface="Calibri"/>
+                        </a:rPr>
+                        <a:t>and </a:t>
+                      </a:r>
+                      <a:r>
+                        <a:rPr lang="en-MY" sz="1050" b="0" dirty="0">
+                          <a:solidFill>
+                            <a:srgbClr val="4E5A66"/>
+                          </a:solidFill>
+                          <a:latin typeface="Calibri"/>
+                        </a:rPr>
+                        <a:t>XenAnalyticDevice.dll</a:t>
+                      </a:r>
+                      <a:r>
+                        <a:rPr sz="1050" b="0" dirty="0">
+                          <a:solidFill>
+                            <a:srgbClr val="4E5A66"/>
+                          </a:solidFill>
+                          <a:latin typeface="Calibri"/>
+                        </a:rPr>
+                        <a:t>, .NET 10</a:t>
                       </a:r>
                     </a:p>
                   </a:txBody>
@@ -7001,8 +7028,8 @@
           </p:nvSpPr>
           <p:spPr>
             <a:xfrm>
-              <a:off x="6800850" y="3202674"/>
-              <a:ext cx="1590675" cy="154698"/>
+              <a:off x="6800850" y="3125325"/>
+              <a:ext cx="1590675" cy="309395"/>
             </a:xfrm>
             <a:prstGeom prst="rect">
               <a:avLst/>
@@ -7017,13 +7044,22 @@
             <a:p>
               <a:pPr algn="l"/>
               <a:r>
+                <a:rPr lang="en-MY" sz="1100" b="1" i="0" u="none" dirty="0">
+                  <a:solidFill>
+                    <a:srgbClr val="0F172A"/>
+                  </a:solidFill>
+                  <a:latin typeface="Plus Jakarta Sans"/>
+                </a:rPr>
+                <a:t>XenAnalyticService.py</a:t>
+              </a:r>
+              <a:r>
                 <a:rPr sz="1100" b="1" i="0" u="none" dirty="0">
                   <a:solidFill>
                     <a:srgbClr val="0F172A"/>
                   </a:solidFill>
                   <a:latin typeface="Plus Jakarta Sans"/>
                 </a:rPr>
-                <a:t>ML Service Prediction</a:t>
+                <a:t> Prediction</a:t>
               </a:r>
             </a:p>
           </p:txBody>
@@ -8874,7 +8910,7 @@
         <p:spPr>
           <a:xfrm>
             <a:off x="820674" y="2627479"/>
-            <a:ext cx="3017520" cy="430887"/>
+            <a:ext cx="3017520" cy="646331"/>
           </a:xfrm>
           <a:prstGeom prst="rect">
             <a:avLst/>
@@ -8889,7 +8925,7 @@
           <a:p>
             <a:pPr algn="l"/>
             <a:r>
-              <a:rPr sz="1400" b="1" i="0" dirty="0">
+              <a:rPr lang="en-MY" sz="1400" b="1" i="0" dirty="0">
                 <a:solidFill>
                   <a:srgbClr val="4E5A66"/>
                 </a:solidFill>
@@ -8898,7 +8934,7 @@
                 </a:highlight>
                 <a:latin typeface="Calibri"/>
               </a:rPr>
-              <a:t>Model.dll </a:t>
+              <a:t>XenAnalyticModel.dll</a:t>
             </a:r>
             <a:r>
               <a:rPr sz="1400" b="0" i="0" dirty="0">
@@ -8910,7 +8946,7 @@
               <a:t>and </a:t>
             </a:r>
             <a:r>
-              <a:rPr sz="1400" b="1" i="0" dirty="0">
+              <a:rPr lang="en-MY" sz="1400" b="1" i="0" dirty="0">
                 <a:solidFill>
                   <a:srgbClr val="4E5A66"/>
                 </a:solidFill>
@@ -8919,7 +8955,7 @@
                 </a:highlight>
                 <a:latin typeface="Calibri"/>
               </a:rPr>
-              <a:t>Logic.dll</a:t>
+              <a:t>XenAnalyticDevice.dll</a:t>
             </a:r>
             <a:r>
               <a:rPr sz="1400" b="0" i="0" dirty="0">
@@ -9071,7 +9107,7 @@
         <p:spPr>
           <a:xfrm>
             <a:off x="4537709" y="2267712"/>
-            <a:ext cx="3017520" cy="457200"/>
+            <a:ext cx="3017520" cy="215380"/>
           </a:xfrm>
           <a:prstGeom prst="rect">
             <a:avLst/>
@@ -9090,13 +9126,31 @@
               </a:lnSpc>
             </a:pPr>
             <a:r>
-              <a:rPr sz="1450" b="1" i="0">
+              <a:rPr sz="1450" b="1" i="0" dirty="0">
                 <a:solidFill>
                   <a:srgbClr val="1B2430"/>
                 </a:solidFill>
                 <a:latin typeface="Cambria"/>
               </a:rPr>
-              <a:t>The ML service address</a:t>
+              <a:t>The </a:t>
+            </a:r>
+            <a:r>
+              <a:rPr lang="en-MY" sz="1450" b="1" i="0" dirty="0">
+                <a:solidFill>
+                  <a:srgbClr val="1B2430"/>
+                </a:solidFill>
+                <a:latin typeface="Cambria"/>
+              </a:rPr>
+              <a:t>XenAnalyticService.py</a:t>
+            </a:r>
+            <a:r>
+              <a:rPr sz="1450" b="1" i="0" dirty="0">
+                <a:solidFill>
+                  <a:srgbClr val="1B2430"/>
+                </a:solidFill>
+                <a:latin typeface="Cambria"/>
+              </a:rPr>
+              <a:t> address</a:t>
             </a:r>
           </a:p>
         </p:txBody>
@@ -9878,7 +9932,25 @@
                 </a:solidFill>
                 <a:latin typeface="Calibri"/>
               </a:rPr>
-              <a:t>runs the whole sequence in one call, against the ML service or local Python. </a:t>
+              <a:t>runs the whole sequence in one call, against the </a:t>
+            </a:r>
+            <a:r>
+              <a:rPr lang="en-MY" sz="1400" b="0" i="0" dirty="0">
+                <a:solidFill>
+                  <a:srgbClr val="4E5A66"/>
+                </a:solidFill>
+                <a:latin typeface="Calibri"/>
+              </a:rPr>
+              <a:t>XenAnalyticService.py</a:t>
+            </a:r>
+            <a:r>
+              <a:rPr sz="1400" b="0" i="0" dirty="0">
+                <a:solidFill>
+                  <a:srgbClr val="4E5A66"/>
+                </a:solidFill>
+                <a:latin typeface="Calibri"/>
+              </a:rPr>
+              <a:t> or local Python. </a:t>
             </a:r>
           </a:p>
         </p:txBody>
@@ -11693,7 +11765,7 @@
         <p:spPr>
           <a:xfrm>
             <a:off x="6821423" y="5175504"/>
-            <a:ext cx="4572000" cy="640080"/>
+            <a:ext cx="4572000" cy="349711"/>
           </a:xfrm>
           <a:prstGeom prst="rect">
             <a:avLst/>
@@ -11712,13 +11784,31 @@
               </a:lnSpc>
             </a:pPr>
             <a:r>
-              <a:rPr sz="1050" b="0" i="0">
+              <a:rPr sz="1050" b="0" i="0" dirty="0">
                 <a:solidFill>
                   <a:srgbClr val="4E5A66"/>
                 </a:solidFill>
                 <a:latin typeface="Calibri"/>
               </a:rPr>
-              <a:t>The single pipeline call now works against either the ML service or local Python, so both apps share one copy of the sequence instead of two.</a:t>
+              <a:t>The single pipeline call now works against either the </a:t>
+            </a:r>
+            <a:r>
+              <a:rPr lang="en-MY" sz="1050" b="0" i="0" dirty="0">
+                <a:solidFill>
+                  <a:srgbClr val="4E5A66"/>
+                </a:solidFill>
+                <a:latin typeface="Calibri"/>
+              </a:rPr>
+              <a:t>XenAnalyticService.py</a:t>
+            </a:r>
+            <a:r>
+              <a:rPr sz="1050" b="0" i="0" dirty="0">
+                <a:solidFill>
+                  <a:srgbClr val="4E5A66"/>
+                </a:solidFill>
+                <a:latin typeface="Calibri"/>
+              </a:rPr>
+              <a:t> or local Python, so both apps share one copy of the sequence instead of two.</a:t>
             </a:r>
           </a:p>
         </p:txBody>
@@ -15147,7 +15237,7 @@
         <p:spPr>
           <a:xfrm>
             <a:off x="4537709" y="2798064"/>
-            <a:ext cx="3017520" cy="658368"/>
+            <a:ext cx="3017520" cy="530979"/>
           </a:xfrm>
           <a:prstGeom prst="rect">
             <a:avLst/>
@@ -15166,13 +15256,31 @@
               </a:lnSpc>
             </a:pPr>
             <a:r>
-              <a:rPr sz="1100" b="0" i="0">
+              <a:rPr sz="1100" b="0" i="0" dirty="0">
                 <a:solidFill>
                   <a:srgbClr val="4E5A66"/>
                 </a:solidFill>
                 <a:latin typeface="Calibri"/>
               </a:rPr>
-              <a:t>Azure DevOps on port 80 and the ML service on port 8000 share 128.100.8.213. Losing it loses both at once.</a:t>
+              <a:t>Azure DevOps on port 80 and the </a:t>
+            </a:r>
+            <a:r>
+              <a:rPr lang="en-MY" sz="1100" b="0" i="0" dirty="0">
+                <a:solidFill>
+                  <a:srgbClr val="4E5A66"/>
+                </a:solidFill>
+                <a:latin typeface="Calibri"/>
+              </a:rPr>
+              <a:t>XenAnalyticService.py</a:t>
+            </a:r>
+            <a:r>
+              <a:rPr sz="1100" b="0" i="0" dirty="0">
+                <a:solidFill>
+                  <a:srgbClr val="4E5A66"/>
+                </a:solidFill>
+                <a:latin typeface="Calibri"/>
+              </a:rPr>
+              <a:t> on port 8000 share 128.100.8.213. Losing it loses both at once.</a:t>
             </a:r>
           </a:p>
         </p:txBody>
@@ -16390,8 +16498,8 @@
         </p:nvSpPr>
         <p:spPr>
           <a:xfrm>
-            <a:off x="5120640" y="1389888"/>
-            <a:ext cx="6263640" cy="768096"/>
+            <a:off x="5120640" y="1586993"/>
+            <a:ext cx="6263640" cy="373885"/>
           </a:xfrm>
           <a:prstGeom prst="rect">
             <a:avLst/>
@@ -16410,13 +16518,49 @@
               </a:lnSpc>
             </a:pPr>
             <a:r>
-              <a:rPr sz="1100" b="0" i="0">
+              <a:rPr sz="1100" b="0" i="0" dirty="0">
                 <a:solidFill>
                   <a:srgbClr val="4E5A66"/>
                 </a:solidFill>
                 <a:latin typeface="Calibri"/>
               </a:rPr>
-              <a:t>.NET 10 runtime, access to the XenCreator database, and network access to the ML service. Python is only needed for the local-prediction console app. Windows x64 only.</a:t>
+              <a:t>.NET 10 runtime, access to the </a:t>
+            </a:r>
+            <a:r>
+              <a:rPr sz="1100" b="0" i="0" dirty="0" err="1">
+                <a:solidFill>
+                  <a:srgbClr val="4E5A66"/>
+                </a:solidFill>
+                <a:latin typeface="Calibri"/>
+              </a:rPr>
+              <a:t>XenCreator</a:t>
+            </a:r>
+            <a:r>
+              <a:rPr sz="1100" b="0" i="0" dirty="0">
+                <a:solidFill>
+                  <a:srgbClr val="4E5A66"/>
+                </a:solidFill>
+                <a:latin typeface="Calibri"/>
+              </a:rPr>
+              <a:t> database, and network access to the </a:t>
+            </a:r>
+            <a:r>
+              <a:rPr lang="en-MY" sz="1100" b="0" i="0" dirty="0">
+                <a:solidFill>
+                  <a:srgbClr val="4E5A66"/>
+                </a:solidFill>
+                <a:latin typeface="Calibri"/>
+              </a:rPr>
+              <a:t>XenAnalyticService.py</a:t>
+            </a:r>
+            <a:r>
+              <a:rPr sz="1100" b="0" i="0" dirty="0">
+                <a:solidFill>
+                  <a:srgbClr val="4E5A66"/>
+                </a:solidFill>
+                <a:latin typeface="Calibri"/>
+              </a:rPr>
+              <a:t>. Python is only needed for the local-prediction console app. Windows x64 only.</a:t>
             </a:r>
           </a:p>
         </p:txBody>
@@ -16869,8 +17013,8 @@
         </p:nvSpPr>
         <p:spPr>
           <a:xfrm>
-            <a:off x="1371600" y="3108960"/>
-            <a:ext cx="3566160" cy="768096"/>
+            <a:off x="1371600" y="3389133"/>
+            <a:ext cx="3566160" cy="207749"/>
           </a:xfrm>
           <a:prstGeom prst="rect">
             <a:avLst/>
@@ -16885,14 +17029,29 @@
           <a:p>
             <a:pPr algn="l"/>
             <a:r>
-              <a:rPr sz="1350" b="1" i="0">
+              <a:rPr sz="1350" b="1" i="0" dirty="0">
                 <a:solidFill>
                   <a:srgbClr val="1B2430"/>
                 </a:solidFill>
                 <a:latin typeface="Cambria"/>
               </a:rPr>
-              <a:t>Run against the ML service</a:t>
-            </a:r>
+              <a:t>Run against the </a:t>
+            </a:r>
+            <a:r>
+              <a:rPr lang="en-MY" sz="1350" b="1" i="0" dirty="0">
+                <a:solidFill>
+                  <a:srgbClr val="1B2430"/>
+                </a:solidFill>
+                <a:latin typeface="Cambria"/>
+              </a:rPr>
+              <a:t>XenAnalyticService.py</a:t>
+            </a:r>
+            <a:endParaRPr sz="1350" b="1" i="0" dirty="0">
+              <a:solidFill>
+                <a:srgbClr val="1B2430"/>
+              </a:solidFill>
+              <a:latin typeface="Cambria"/>
+            </a:endParaRPr>
           </a:p>
         </p:txBody>
       </p:sp>
@@ -17510,8 +17669,8 @@
         </p:nvSpPr>
         <p:spPr>
           <a:xfrm>
-            <a:off x="868680" y="5724144"/>
-            <a:ext cx="10424160" cy="475488"/>
+            <a:off x="868680" y="5869555"/>
+            <a:ext cx="10424160" cy="184666"/>
           </a:xfrm>
           <a:prstGeom prst="rect">
             <a:avLst/>
@@ -17526,13 +17685,85 @@
           <a:p>
             <a:pPr algn="ctr"/>
             <a:r>
-              <a:rPr sz="1200" b="0" i="0">
+              <a:rPr sz="1200" b="0" i="0" dirty="0">
                 <a:solidFill>
                   <a:srgbClr val="FFFFFF"/>
                 </a:solidFill>
                 <a:latin typeface="Calibri"/>
               </a:rPr>
-              <a:t>For a user interface: reference Logic.dll and call DevicePipeline.RunAsync(…), passing HttpPredictionClient to use the ML service.</a:t>
+              <a:t>For a user interface: reference </a:t>
+            </a:r>
+            <a:r>
+              <a:rPr lang="en-MY" sz="1200" b="0" i="0" dirty="0">
+                <a:solidFill>
+                  <a:srgbClr val="FFFFFF"/>
+                </a:solidFill>
+                <a:latin typeface="Calibri"/>
+              </a:rPr>
+              <a:t>XenAnalyticDevice.dll</a:t>
+            </a:r>
+            <a:r>
+              <a:rPr sz="1200" b="0" i="0" dirty="0">
+                <a:solidFill>
+                  <a:srgbClr val="FFFFFF"/>
+                </a:solidFill>
+                <a:latin typeface="Calibri"/>
+              </a:rPr>
+              <a:t> and call </a:t>
+            </a:r>
+            <a:r>
+              <a:rPr sz="1200" b="0" i="0" dirty="0" err="1">
+                <a:solidFill>
+                  <a:srgbClr val="FFFFFF"/>
+                </a:solidFill>
+                <a:latin typeface="Calibri"/>
+              </a:rPr>
+              <a:t>DevicePipeline.RunAsync</a:t>
+            </a:r>
+            <a:r>
+              <a:rPr sz="1200" b="0" i="0" dirty="0">
+                <a:solidFill>
+                  <a:srgbClr val="FFFFFF"/>
+                </a:solidFill>
+                <a:latin typeface="Calibri"/>
+              </a:rPr>
+              <a:t>(…), passing </a:t>
+            </a:r>
+            <a:r>
+              <a:rPr sz="1200" b="0" i="0" dirty="0" err="1">
+                <a:solidFill>
+                  <a:srgbClr val="FFFFFF"/>
+                </a:solidFill>
+                <a:latin typeface="Calibri"/>
+              </a:rPr>
+              <a:t>HttpPredictionClient</a:t>
+            </a:r>
+            <a:r>
+              <a:rPr sz="1200" b="0" i="0" dirty="0">
+                <a:solidFill>
+                  <a:srgbClr val="FFFFFF"/>
+                </a:solidFill>
+                <a:latin typeface="Calibri"/>
+              </a:rPr>
+              <a:t> to use the </a:t>
+            </a:r>
+            <a:r>
+              <a:rPr lang="en-MY" sz="1200" b="0" i="0" dirty="0">
+                <a:solidFill>
+                  <a:srgbClr val="FFFFFF"/>
+                </a:solidFill>
+                <a:latin typeface="Calibri"/>
+              </a:rPr>
+              <a:t>XenAnalyticService.py</a:t>
+            </a:r>
+            <a:r>
+              <a:rPr sz="1200" b="0" i="0" dirty="0">
+                <a:solidFill>
+                  <a:srgbClr val="FFFFFF"/>
+                </a:solidFill>
+                <a:latin typeface="Calibri"/>
+              </a:rPr>
+              <a:t>.</a:t>
             </a:r>
           </a:p>
         </p:txBody>
@@ -29048,8 +29279,8 @@
         </p:nvSpPr>
         <p:spPr>
           <a:xfrm>
-            <a:off x="804672" y="2304288"/>
-            <a:ext cx="2194560" cy="713232"/>
+            <a:off x="804672" y="2557029"/>
+            <a:ext cx="2194560" cy="207749"/>
           </a:xfrm>
           <a:prstGeom prst="rect">
             <a:avLst/>
@@ -29064,14 +29295,20 @@
           <a:p>
             <a:pPr algn="l"/>
             <a:r>
-              <a:rPr sz="1350" b="1" i="0">
+              <a:rPr lang="en-MY" sz="1350" b="1" i="0" dirty="0">
                 <a:solidFill>
                   <a:srgbClr val="1B2430"/>
                 </a:solidFill>
                 <a:latin typeface="Cambria"/>
               </a:rPr>
-              <a:t>Logic.dll</a:t>
-            </a:r>
+              <a:t>XenAnalyticDevice.dll</a:t>
+            </a:r>
+            <a:endParaRPr sz="1350" b="1" i="0" dirty="0">
+              <a:solidFill>
+                <a:srgbClr val="1B2430"/>
+              </a:solidFill>
+              <a:latin typeface="Cambria"/>
+            </a:endParaRPr>
           </a:p>
         </p:txBody>
       </p:sp>
@@ -29171,8 +29408,8 @@
         </p:nvSpPr>
         <p:spPr>
           <a:xfrm>
-            <a:off x="804672" y="3145536"/>
-            <a:ext cx="2194560" cy="713232"/>
+            <a:off x="804672" y="3398277"/>
+            <a:ext cx="2194560" cy="207749"/>
           </a:xfrm>
           <a:prstGeom prst="rect">
             <a:avLst/>
@@ -29187,14 +29424,20 @@
           <a:p>
             <a:pPr algn="l"/>
             <a:r>
-              <a:rPr sz="1350" b="1" i="0">
+              <a:rPr lang="en-MY" sz="1350" b="1" i="0" dirty="0">
                 <a:solidFill>
                   <a:srgbClr val="1B2430"/>
                 </a:solidFill>
                 <a:latin typeface="Cambria"/>
               </a:rPr>
-              <a:t>Model.dll</a:t>
-            </a:r>
+              <a:t>XenAnalyticDevice.dll</a:t>
+            </a:r>
+            <a:endParaRPr sz="1350" b="1" i="0" dirty="0">
+              <a:solidFill>
+                <a:srgbClr val="1B2430"/>
+              </a:solidFill>
+              <a:latin typeface="Cambria"/>
+            </a:endParaRPr>
           </a:p>
         </p:txBody>
       </p:sp>
@@ -29294,8 +29537,8 @@
         </p:nvSpPr>
         <p:spPr>
           <a:xfrm>
-            <a:off x="804672" y="3986784"/>
-            <a:ext cx="2194560" cy="713232"/>
+            <a:off x="804672" y="4239525"/>
+            <a:ext cx="2194560" cy="207749"/>
           </a:xfrm>
           <a:prstGeom prst="rect">
             <a:avLst/>
@@ -29310,14 +29553,20 @@
           <a:p>
             <a:pPr algn="l"/>
             <a:r>
-              <a:rPr sz="1350" b="1" i="0">
+              <a:rPr lang="en-MY" sz="1350" b="1" i="0" dirty="0">
                 <a:solidFill>
                   <a:srgbClr val="1B2430"/>
                 </a:solidFill>
                 <a:latin typeface="Cambria"/>
               </a:rPr>
-              <a:t>ML service</a:t>
-            </a:r>
+              <a:t>XenAnalyticService.py</a:t>
+            </a:r>
+            <a:endParaRPr sz="1350" b="1" i="0" dirty="0">
+              <a:solidFill>
+                <a:srgbClr val="1B2430"/>
+              </a:solidFill>
+              <a:latin typeface="Cambria"/>
+            </a:endParaRPr>
           </a:p>
         </p:txBody>
       </p:sp>
@@ -29796,7 +30045,7 @@
         <p:spPr>
           <a:xfrm>
             <a:off x="7114032" y="3639312"/>
-            <a:ext cx="4270248" cy="548640"/>
+            <a:ext cx="4270248" cy="422167"/>
           </a:xfrm>
           <a:prstGeom prst="rect">
             <a:avLst/>
@@ -29815,7 +30064,7 @@
               </a:lnSpc>
             </a:pPr>
             <a:r>
-              <a:rPr sz="1200" b="0" i="0">
+              <a:rPr sz="1200" b="0" i="0" dirty="0">
                 <a:solidFill>
                   <a:srgbClr val="1B2430"/>
                 </a:solidFill>
@@ -29831,13 +30080,31 @@
               </a:lnSpc>
             </a:pPr>
             <a:r>
-              <a:rPr sz="1200" b="0" i="0">
+              <a:rPr sz="1200" b="0" i="0" dirty="0">
                 <a:solidFill>
                   <a:srgbClr val="1B2430"/>
                 </a:solidFill>
                 <a:latin typeface="Calibri"/>
               </a:rPr>
-              <a:t>SQL Server  ·  ML service reachable</a:t>
+              <a:t>SQL Server  ·  </a:t>
+            </a:r>
+            <a:r>
+              <a:rPr lang="en-MY" sz="1200" b="0" i="0" dirty="0">
+                <a:solidFill>
+                  <a:srgbClr val="1B2430"/>
+                </a:solidFill>
+                <a:latin typeface="Calibri"/>
+              </a:rPr>
+              <a:t>XenAnalyticService.py</a:t>
+            </a:r>
+            <a:r>
+              <a:rPr sz="1200" b="0" i="0" dirty="0">
+                <a:solidFill>
+                  <a:srgbClr val="1B2430"/>
+                </a:solidFill>
+                <a:latin typeface="Calibri"/>
+              </a:rPr>
+              <a:t> reachable</a:t>
             </a:r>
           </a:p>
         </p:txBody>

</xml_diff>